<commit_message>
phase 4: figure extraction + vision descriptions, Whisper audio/video ingestion, source viewer endpoints, transcript timestamp fix
Co-Authored-By: Claude Sonnet 5.5 <noreply@anthropic.com>
</commit_message>
<xml_diff>
--- a/data/sample_courses/ml/lecture_slides.pptx
+++ b/data/sample_courses/ml/lecture_slides.pptx
@@ -10,6 +10,7 @@
     <p:sldId id="258" r:id="rId10"/>
     <p:sldId id="259" r:id="rId11"/>
     <p:sldId id="260" r:id="rId12"/>
+    <p:sldId id="261" r:id="rId13"/>
   </p:sldIdLst>
   <p:sldSz cx="12188952" cy="6858000" type="screen4x3"/>
   <p:notesSz cx="6858000" cy="9144000"/>
@@ -787,6 +788,76 @@
           <a:p>
             <a:r>
               <a:t>Explain: Overfitting: great on train, poor on new data / L2 (ridge): lambda * ||w||^2 — smooth shrinkage / L1 (lasso): lambda * ||w||_1 — sparse, feature selection / Tune lambda on validation, report on test</a:t>
+            </a:r>
+          </a:p>
+        </p:txBody>
+      </p:sp>
+      <p:sp>
+        <p:nvSpPr>
+          <p:cNvPr id="4" name="Slide Number Placeholder 3"/>
+          <p:cNvSpPr>
+            <a:spLocks noGrp="1"/>
+          </p:cNvSpPr>
+          <p:nvPr>
+            <p:ph type="sldNum" idx="5" sz="quarter"/>
+          </p:nvPr>
+        </p:nvSpPr>
+        <p:spPr/>
+      </p:sp>
+    </p:spTree>
+  </p:cSld>
+  <p:clrMapOvr>
+    <a:masterClrMapping/>
+  </p:clrMapOvr>
+</p:notes>
+</file>
+
+<file path=ppt/notesSlides/notesSlide6.xml><?xml version="1.0" encoding="utf-8"?>
+<p:notes xmlns:a="http://schemas.openxmlformats.org/drawingml/2006/main" xmlns:p="http://schemas.openxmlformats.org/presentationml/2006/main" xmlns:r="http://schemas.openxmlformats.org/officeDocument/2006/relationships">
+  <p:cSld>
+    <p:spTree>
+      <p:nvGrpSpPr>
+        <p:cNvPr id="1" name=""/>
+        <p:cNvGrpSpPr/>
+        <p:nvPr/>
+      </p:nvGrpSpPr>
+      <p:grpSpPr>
+        <a:xfrm>
+          <a:off x="0" y="0"/>
+          <a:ext cx="0" cy="0"/>
+          <a:chOff x="0" y="0"/>
+          <a:chExt cx="0" cy="0"/>
+        </a:xfrm>
+      </p:grpSpPr>
+      <p:sp>
+        <p:nvSpPr>
+          <p:cNvPr id="2" name="Slide Image Placeholder 1"/>
+          <p:cNvSpPr>
+            <a:spLocks noGrp="1"/>
+          </p:cNvSpPr>
+          <p:nvPr>
+            <p:ph type="sldImg" idx="2"/>
+          </p:nvPr>
+        </p:nvSpPr>
+        <p:spPr/>
+      </p:sp>
+      <p:sp>
+        <p:nvSpPr>
+          <p:cNvPr id="3" name="Notes Placeholder 2"/>
+          <p:cNvSpPr>
+            <a:spLocks noGrp="1"/>
+          </p:cNvSpPr>
+          <p:nvPr>
+            <p:ph type="body" idx="3" sz="quarter"/>
+          </p:nvPr>
+        </p:nvSpPr>
+        <p:spPr/>
+        <p:txBody>
+          <a:bodyPr/>
+          <a:lstStyle/>
+          <a:p>
+            <a:r>
+              <a:t>Walk through the figure with the class.</a:t>
             </a:r>
           </a:p>
         </p:txBody>
@@ -3848,7 +3919,7 @@
           <a:noFill/>
         </p:spPr>
         <p:txBody>
-          <a:bodyPr wrap="none">
+          <a:bodyPr wrap="square">
             <a:spAutoFit/>
           </a:bodyPr>
           <a:lstStyle/>
@@ -3961,7 +4032,7 @@
           <a:noFill/>
         </p:spPr>
         <p:txBody>
-          <a:bodyPr wrap="none">
+          <a:bodyPr wrap="square">
             <a:spAutoFit/>
           </a:bodyPr>
           <a:lstStyle/>
@@ -4074,7 +4145,7 @@
           <a:noFill/>
         </p:spPr>
         <p:txBody>
-          <a:bodyPr wrap="none">
+          <a:bodyPr wrap="square">
             <a:spAutoFit/>
           </a:bodyPr>
           <a:lstStyle/>
@@ -4198,7 +4269,7 @@
           <a:noFill/>
         </p:spPr>
         <p:txBody>
-          <a:bodyPr wrap="none">
+          <a:bodyPr wrap="square">
             <a:spAutoFit/>
           </a:bodyPr>
           <a:lstStyle/>
@@ -4311,7 +4382,7 @@
           <a:noFill/>
         </p:spPr>
         <p:txBody>
-          <a:bodyPr wrap="none">
+          <a:bodyPr wrap="square">
             <a:spAutoFit/>
           </a:bodyPr>
           <a:lstStyle/>
@@ -4361,6 +4432,132 @@
           </a:p>
         </p:txBody>
       </p:sp>
+    </p:spTree>
+  </p:cSld>
+  <p:clrMapOvr>
+    <a:masterClrMapping/>
+  </p:clrMapOvr>
+</p:sld>
+</file>
+
+<file path=ppt/slides/slide6.xml><?xml version="1.0" encoding="utf-8"?>
+<p:sld xmlns:a="http://schemas.openxmlformats.org/drawingml/2006/main" xmlns:p="http://schemas.openxmlformats.org/presentationml/2006/main" xmlns:r="http://schemas.openxmlformats.org/officeDocument/2006/relationships">
+  <p:cSld>
+    <p:spTree>
+      <p:nvGrpSpPr>
+        <p:cNvPr id="1" name=""/>
+        <p:cNvGrpSpPr/>
+        <p:nvPr/>
+      </p:nvGrpSpPr>
+      <p:grpSpPr/>
+      <p:sp>
+        <p:nvSpPr>
+          <p:cNvPr id="2" name="TextBox 1"/>
+          <p:cNvSpPr txBox="1"/>
+          <p:nvPr/>
+        </p:nvSpPr>
+        <p:spPr>
+          <a:xfrm>
+            <a:off x="640080" y="457200"/>
+            <a:ext cx="10972800" cy="1280160"/>
+          </a:xfrm>
+          <a:prstGeom prst="rect">
+            <a:avLst/>
+          </a:prstGeom>
+          <a:noFill/>
+        </p:spPr>
+        <p:txBody>
+          <a:bodyPr wrap="none">
+            <a:spAutoFit/>
+          </a:bodyPr>
+          <a:lstStyle/>
+          <a:p>
+            <a:pPr>
+              <a:defRPr sz="3400" b="1"/>
+            </a:pPr>
+            <a:r>
+              <a:t>Choosing the Learning Rate</a:t>
+            </a:r>
+          </a:p>
+          <a:p>
+            <a:pPr>
+              <a:defRPr sz="1700"/>
+            </a:pPr>
+            <a:r>
+              <a:t>Reading the loss curve</a:t>
+            </a:r>
+          </a:p>
+        </p:txBody>
+      </p:sp>
+      <p:sp>
+        <p:nvSpPr>
+          <p:cNvPr id="3" name="TextBox 2"/>
+          <p:cNvSpPr txBox="1"/>
+          <p:nvPr/>
+        </p:nvSpPr>
+        <p:spPr>
+          <a:xfrm>
+            <a:off x="822960" y="2011680"/>
+            <a:ext cx="5303520" cy="4114800"/>
+          </a:xfrm>
+          <a:prstGeom prst="rect">
+            <a:avLst/>
+          </a:prstGeom>
+          <a:noFill/>
+        </p:spPr>
+        <p:txBody>
+          <a:bodyPr wrap="square">
+            <a:spAutoFit/>
+          </a:bodyPr>
+          <a:lstStyle/>
+          <a:p>
+            <a:pPr>
+              <a:spcAft>
+                <a:spcPts val="1400"/>
+              </a:spcAft>
+              <a:defRPr sz="2000"/>
+            </a:pPr>
+            <a:r>
+              <a:t>•  Plot the training loss every iteration</a:t>
+            </a:r>
+          </a:p>
+          <a:p>
+            <a:pPr>
+              <a:spcAft>
+                <a:spcPts val="1400"/>
+              </a:spcAft>
+              <a:defRPr sz="2000"/>
+            </a:pPr>
+            <a:r>
+              <a:t>•  Compare three step sizes side by side</a:t>
+            </a:r>
+          </a:p>
+        </p:txBody>
+      </p:sp>
+      <p:pic>
+        <p:nvPicPr>
+          <p:cNvPr id="4" name="Picture 3" descr="fig_learning_rates.png"/>
+          <p:cNvPicPr>
+            <a:picLocks noChangeAspect="1"/>
+          </p:cNvPicPr>
+          <p:nvPr/>
+        </p:nvPicPr>
+        <p:blipFill>
+          <a:blip r:embed="rId2"/>
+          <a:stretch>
+            <a:fillRect/>
+          </a:stretch>
+        </p:blipFill>
+        <p:spPr>
+          <a:xfrm>
+            <a:off x="6309360" y="1737360"/>
+            <a:ext cx="5394960" cy="3236976"/>
+          </a:xfrm>
+          <a:prstGeom prst="rect">
+            <a:avLst/>
+          </a:prstGeom>
+        </p:spPr>
+      </p:pic>
     </p:spTree>
   </p:cSld>
   <p:clrMapOvr>

</xml_diff>